<commit_message>
Chronell 0.9.12 - Signatur + Bookings
</commit_message>
<xml_diff>
--- a/resources/branding/Chronell-Logo.pptx
+++ b/resources/branding/Chronell-Logo.pptx
@@ -5,10 +5,10 @@
     <p:sldMasterId id="2147483648" r:id="rId1"/>
   </p:sldMasterIdLst>
   <p:sldIdLst>
-    <p:sldId id="256" r:id="rId2"/>
-    <p:sldId id="258" r:id="rId3"/>
-    <p:sldId id="259" r:id="rId4"/>
-    <p:sldId id="257" r:id="rId5"/>
+    <p:sldId id="257" r:id="rId2"/>
+    <p:sldId id="256" r:id="rId3"/>
+    <p:sldId id="258" r:id="rId4"/>
+    <p:sldId id="259" r:id="rId5"/>
   </p:sldIdLst>
   <p:sldSz cx="12192000" cy="6858000"/>
   <p:notesSz cx="6858000" cy="9144000"/>
@@ -3347,6 +3347,369 @@
       </p:grpSpPr>
       <p:sp>
         <p:nvSpPr>
+          <p:cNvPr id="8" name="Freihandform: Form 7">
+            <a:extLst>
+              <a:ext uri="{FF2B5EF4-FFF2-40B4-BE49-F238E27FC236}">
+                <a16:creationId xmlns:a16="http://schemas.microsoft.com/office/drawing/2014/main" id="{8CDF04D5-40C1-D473-1A0C-67F3FD82D515}"/>
+              </a:ext>
+            </a:extLst>
+          </p:cNvPr>
+          <p:cNvSpPr/>
+          <p:nvPr/>
+        </p:nvSpPr>
+        <p:spPr>
+          <a:xfrm rot="19800000">
+            <a:off x="162768" y="1719631"/>
+            <a:ext cx="7200000" cy="1846906"/>
+          </a:xfrm>
+          <a:custGeom>
+            <a:avLst/>
+            <a:gdLst>
+              <a:gd name="csX0" fmla="*/ 6765499 w 7200000"/>
+              <a:gd name="csY0" fmla="*/ 252113 h 1846906"/>
+              <a:gd name="csX1" fmla="*/ 7200000 w 7200000"/>
+              <a:gd name="csY1" fmla="*/ 766906 h 1846906"/>
+              <a:gd name="csX2" fmla="*/ 3600000 w 7200000"/>
+              <a:gd name="csY2" fmla="*/ 1846906 h 1846906"/>
+              <a:gd name="csX3" fmla="*/ 0 w 7200000"/>
+              <a:gd name="csY3" fmla="*/ 766906 h 1846906"/>
+              <a:gd name="csX4" fmla="*/ 1054416 w 7200000"/>
+              <a:gd name="csY4" fmla="*/ 3231 h 1846906"/>
+              <a:gd name="csX5" fmla="*/ 1066264 w 7200000"/>
+              <a:gd name="csY5" fmla="*/ 0 h 1846906"/>
+              <a:gd name="csX6" fmla="*/ 1043666 w 7200000"/>
+              <a:gd name="csY6" fmla="*/ 9117 h 1846906"/>
+              <a:gd name="csX7" fmla="*/ 500451 w 7200000"/>
+              <a:gd name="csY7" fmla="*/ 545649 h 1846906"/>
+              <a:gd name="csX8" fmla="*/ 3681164 w 7200000"/>
+              <a:gd name="csY8" fmla="*/ 1505268 h 1846906"/>
+              <a:gd name="csX9" fmla="*/ 6861878 w 7200000"/>
+              <a:gd name="csY9" fmla="*/ 545649 h 1846906"/>
+              <a:gd name="csX10" fmla="*/ 6718880 w 7200000"/>
+              <a:gd name="csY10" fmla="*/ 260288 h 1846906"/>
+              <a:gd name="csX11" fmla="*/ 6624488 w 7200000"/>
+              <a:gd name="csY11" fmla="*/ 182480 h 1846906"/>
+            </a:gdLst>
+            <a:ahLst/>
+            <a:cxnLst>
+              <a:cxn ang="0">
+                <a:pos x="csX0" y="csY0"/>
+              </a:cxn>
+              <a:cxn ang="0">
+                <a:pos x="csX1" y="csY1"/>
+              </a:cxn>
+              <a:cxn ang="0">
+                <a:pos x="csX2" y="csY2"/>
+              </a:cxn>
+              <a:cxn ang="0">
+                <a:pos x="csX3" y="csY3"/>
+              </a:cxn>
+              <a:cxn ang="0">
+                <a:pos x="csX4" y="csY4"/>
+              </a:cxn>
+              <a:cxn ang="0">
+                <a:pos x="csX5" y="csY5"/>
+              </a:cxn>
+              <a:cxn ang="0">
+                <a:pos x="csX6" y="csY6"/>
+              </a:cxn>
+              <a:cxn ang="0">
+                <a:pos x="csX7" y="csY7"/>
+              </a:cxn>
+              <a:cxn ang="0">
+                <a:pos x="csX8" y="csY8"/>
+              </a:cxn>
+              <a:cxn ang="0">
+                <a:pos x="csX9" y="csY9"/>
+              </a:cxn>
+              <a:cxn ang="0">
+                <a:pos x="csX10" y="csY10"/>
+              </a:cxn>
+              <a:cxn ang="0">
+                <a:pos x="csX11" y="csY11"/>
+              </a:cxn>
+            </a:cxnLst>
+            <a:rect l="l" t="t" r="r" b="b"/>
+            <a:pathLst>
+              <a:path w="7200000" h="1846906">
+                <a:moveTo>
+                  <a:pt x="6765499" y="252113"/>
+                </a:moveTo>
+                <a:cubicBezTo>
+                  <a:pt x="7042600" y="405142"/>
+                  <a:pt x="7200000" y="580510"/>
+                  <a:pt x="7200000" y="766906"/>
+                </a:cubicBezTo>
+                <a:cubicBezTo>
+                  <a:pt x="7200000" y="1363374"/>
+                  <a:pt x="5588225" y="1846906"/>
+                  <a:pt x="3600000" y="1846906"/>
+                </a:cubicBezTo>
+                <a:cubicBezTo>
+                  <a:pt x="1611775" y="1846906"/>
+                  <a:pt x="0" y="1363374"/>
+                  <a:pt x="0" y="766906"/>
+                </a:cubicBezTo>
+                <a:cubicBezTo>
+                  <a:pt x="0" y="468672"/>
+                  <a:pt x="402944" y="198672"/>
+                  <a:pt x="1054416" y="3231"/>
+                </a:cubicBezTo>
+                <a:lnTo>
+                  <a:pt x="1066264" y="0"/>
+                </a:lnTo>
+                <a:lnTo>
+                  <a:pt x="1043666" y="9117"/>
+                </a:lnTo>
+                <a:cubicBezTo>
+                  <a:pt x="700708" y="162273"/>
+                  <a:pt x="500451" y="346905"/>
+                  <a:pt x="500451" y="545649"/>
+                </a:cubicBezTo>
+                <a:cubicBezTo>
+                  <a:pt x="500450" y="1075632"/>
+                  <a:pt x="1924505" y="1505268"/>
+                  <a:pt x="3681164" y="1505268"/>
+                </a:cubicBezTo>
+                <a:cubicBezTo>
+                  <a:pt x="5437825" y="1505268"/>
+                  <a:pt x="6861879" y="1075632"/>
+                  <a:pt x="6861878" y="545649"/>
+                </a:cubicBezTo>
+                <a:cubicBezTo>
+                  <a:pt x="6861878" y="446277"/>
+                  <a:pt x="6811814" y="350433"/>
+                  <a:pt x="6718880" y="260288"/>
+                </a:cubicBezTo>
+                <a:lnTo>
+                  <a:pt x="6624488" y="182480"/>
+                </a:lnTo>
+                <a:close/>
+              </a:path>
+            </a:pathLst>
+          </a:custGeom>
+          <a:gradFill>
+            <a:gsLst>
+              <a:gs pos="100000">
+                <a:srgbClr val="7C6FE1"/>
+              </a:gs>
+              <a:gs pos="0">
+                <a:srgbClr val="424CD0"/>
+              </a:gs>
+            </a:gsLst>
+            <a:lin ang="0" scaled="0"/>
+          </a:gradFill>
+          <a:ln>
+            <a:noFill/>
+          </a:ln>
+        </p:spPr>
+        <p:style>
+          <a:lnRef idx="2">
+            <a:schemeClr val="accent1">
+              <a:shade val="15000"/>
+            </a:schemeClr>
+          </a:lnRef>
+          <a:fillRef idx="1">
+            <a:schemeClr val="accent1"/>
+          </a:fillRef>
+          <a:effectRef idx="0">
+            <a:schemeClr val="accent1"/>
+          </a:effectRef>
+          <a:fontRef idx="minor">
+            <a:schemeClr val="lt1"/>
+          </a:fontRef>
+        </p:style>
+        <p:txBody>
+          <a:bodyPr wrap="square" rtlCol="0" anchor="ctr">
+            <a:noAutofit/>
+          </a:bodyPr>
+          <a:lstStyle/>
+          <a:p>
+            <a:pPr algn="ctr"/>
+            <a:endParaRPr lang="de-AT"/>
+          </a:p>
+        </p:txBody>
+      </p:sp>
+      <p:sp>
+        <p:nvSpPr>
+          <p:cNvPr id="6" name="Ellipse 5">
+            <a:extLst>
+              <a:ext uri="{FF2B5EF4-FFF2-40B4-BE49-F238E27FC236}">
+                <a16:creationId xmlns:a16="http://schemas.microsoft.com/office/drawing/2014/main" id="{9C6FF0E6-4E39-6A20-A086-1E7BC09924AD}"/>
+              </a:ext>
+            </a:extLst>
+          </p:cNvPr>
+          <p:cNvSpPr/>
+          <p:nvPr/>
+        </p:nvSpPr>
+        <p:spPr>
+          <a:xfrm rot="19800000">
+            <a:off x="3280507" y="3042693"/>
+            <a:ext cx="7200000" cy="2160000"/>
+          </a:xfrm>
+          <a:prstGeom prst="ellipse">
+            <a:avLst/>
+          </a:prstGeom>
+          <a:gradFill>
+            <a:gsLst>
+              <a:gs pos="100000">
+                <a:srgbClr val="7C6FE1"/>
+              </a:gs>
+              <a:gs pos="0">
+                <a:srgbClr val="424CD0"/>
+              </a:gs>
+            </a:gsLst>
+            <a:lin ang="0" scaled="0"/>
+          </a:gradFill>
+          <a:ln>
+            <a:noFill/>
+          </a:ln>
+        </p:spPr>
+        <p:style>
+          <a:lnRef idx="2">
+            <a:schemeClr val="accent1">
+              <a:shade val="15000"/>
+            </a:schemeClr>
+          </a:lnRef>
+          <a:fillRef idx="1">
+            <a:schemeClr val="accent1"/>
+          </a:fillRef>
+          <a:effectRef idx="0">
+            <a:schemeClr val="accent1"/>
+          </a:effectRef>
+          <a:fontRef idx="minor">
+            <a:schemeClr val="lt1"/>
+          </a:fontRef>
+        </p:style>
+        <p:txBody>
+          <a:bodyPr rtlCol="0" anchor="ctr"/>
+          <a:lstStyle/>
+          <a:p>
+            <a:pPr algn="ctr"/>
+            <a:endParaRPr lang="de-AT"/>
+          </a:p>
+        </p:txBody>
+      </p:sp>
+      <p:sp>
+        <p:nvSpPr>
+          <p:cNvPr id="7" name="Ellipse 6">
+            <a:extLst>
+              <a:ext uri="{FF2B5EF4-FFF2-40B4-BE49-F238E27FC236}">
+                <a16:creationId xmlns:a16="http://schemas.microsoft.com/office/drawing/2014/main" id="{3D62D169-E9A3-EB61-1F83-FA51E5E46D59}"/>
+              </a:ext>
+            </a:extLst>
+          </p:cNvPr>
+          <p:cNvSpPr/>
+          <p:nvPr/>
+        </p:nvSpPr>
+        <p:spPr>
+          <a:xfrm rot="19800000">
+            <a:off x="3724568" y="2863533"/>
+            <a:ext cx="6420723" cy="1926217"/>
+          </a:xfrm>
+          <a:prstGeom prst="ellipse">
+            <a:avLst/>
+          </a:prstGeom>
+          <a:solidFill>
+            <a:schemeClr val="bg1"/>
+          </a:solidFill>
+          <a:ln>
+            <a:noFill/>
+          </a:ln>
+        </p:spPr>
+        <p:style>
+          <a:lnRef idx="2">
+            <a:schemeClr val="accent1">
+              <a:shade val="15000"/>
+            </a:schemeClr>
+          </a:lnRef>
+          <a:fillRef idx="1">
+            <a:schemeClr val="accent1"/>
+          </a:fillRef>
+          <a:effectRef idx="0">
+            <a:schemeClr val="accent1"/>
+          </a:effectRef>
+          <a:fontRef idx="minor">
+            <a:schemeClr val="lt1"/>
+          </a:fontRef>
+        </p:style>
+        <p:txBody>
+          <a:bodyPr rtlCol="0" anchor="ctr"/>
+          <a:lstStyle/>
+          <a:p>
+            <a:pPr algn="ctr"/>
+            <a:endParaRPr lang="de-AT"/>
+          </a:p>
+        </p:txBody>
+      </p:sp>
+      <p:pic>
+        <p:nvPicPr>
+          <p:cNvPr id="13" name="Grafik 12">
+            <a:extLst>
+              <a:ext uri="{FF2B5EF4-FFF2-40B4-BE49-F238E27FC236}">
+                <a16:creationId xmlns:a16="http://schemas.microsoft.com/office/drawing/2014/main" id="{CCB98D3A-CEF0-BE6D-8279-E05FD762A062}"/>
+              </a:ext>
+            </a:extLst>
+          </p:cNvPr>
+          <p:cNvPicPr>
+            <a:picLocks noChangeAspect="1"/>
+          </p:cNvPicPr>
+          <p:nvPr/>
+        </p:nvPicPr>
+        <p:blipFill>
+          <a:blip r:embed="rId2">
+            <a:extLst>
+              <a:ext uri="{28A0092B-C50C-407E-A947-70E740481C1C}">
+                <a14:useLocalDpi xmlns:a14="http://schemas.microsoft.com/office/drawing/2010/main" val="0"/>
+              </a:ext>
+            </a:extLst>
+          </a:blip>
+          <a:stretch>
+            <a:fillRect/>
+          </a:stretch>
+        </p:blipFill>
+        <p:spPr>
+          <a:xfrm>
+            <a:off x="209372" y="339690"/>
+            <a:ext cx="2388551" cy="2388551"/>
+          </a:xfrm>
+          <a:prstGeom prst="rect">
+            <a:avLst/>
+          </a:prstGeom>
+        </p:spPr>
+      </p:pic>
+    </p:spTree>
+    <p:extLst>
+      <p:ext uri="{BB962C8B-B14F-4D97-AF65-F5344CB8AC3E}">
+        <p14:creationId xmlns:p14="http://schemas.microsoft.com/office/powerpoint/2010/main" val="3583143208"/>
+      </p:ext>
+    </p:extLst>
+  </p:cSld>
+  <p:clrMapOvr>
+    <a:masterClrMapping/>
+  </p:clrMapOvr>
+</p:sld>
+</file>
+
+<file path=ppt/slides/slide2.xml><?xml version="1.0" encoding="utf-8"?>
+<p:sld xmlns:a="http://schemas.openxmlformats.org/drawingml/2006/main" xmlns:r="http://schemas.openxmlformats.org/officeDocument/2006/relationships" xmlns:p="http://schemas.openxmlformats.org/presentationml/2006/main">
+  <p:cSld>
+    <p:spTree>
+      <p:nvGrpSpPr>
+        <p:cNvPr id="1" name=""/>
+        <p:cNvGrpSpPr/>
+        <p:nvPr/>
+      </p:nvGrpSpPr>
+      <p:grpSpPr>
+        <a:xfrm>
+          <a:off x="0" y="0"/>
+          <a:ext cx="0" cy="0"/>
+          <a:chOff x="0" y="0"/>
+          <a:chExt cx="0" cy="0"/>
+        </a:xfrm>
+      </p:grpSpPr>
+      <p:sp>
+        <p:nvSpPr>
           <p:cNvPr id="35" name="Freihandform: Form 34">
             <a:extLst>
               <a:ext uri="{FF2B5EF4-FFF2-40B4-BE49-F238E27FC236}">
@@ -4191,7 +4554,7 @@
 </p:sld>
 </file>
 
-<file path=ppt/slides/slide2.xml><?xml version="1.0" encoding="utf-8"?>
+<file path=ppt/slides/slide3.xml><?xml version="1.0" encoding="utf-8"?>
 <p:sld xmlns:a="http://schemas.openxmlformats.org/drawingml/2006/main" xmlns:r="http://schemas.openxmlformats.org/officeDocument/2006/relationships" xmlns:p="http://schemas.openxmlformats.org/presentationml/2006/main">
   <p:cSld>
     <p:spTree>
@@ -4937,7 +5300,7 @@
 </p:sld>
 </file>
 
-<file path=ppt/slides/slide3.xml><?xml version="1.0" encoding="utf-8"?>
+<file path=ppt/slides/slide4.xml><?xml version="1.0" encoding="utf-8"?>
 <p:sld xmlns:a="http://schemas.openxmlformats.org/drawingml/2006/main" xmlns:r="http://schemas.openxmlformats.org/officeDocument/2006/relationships" xmlns:p="http://schemas.openxmlformats.org/presentationml/2006/main">
   <p:cSld>
     <p:spTree>
@@ -5268,42 +5631,6 @@
           </a:p>
         </p:txBody>
       </p:sp>
-      <p:pic>
-        <p:nvPicPr>
-          <p:cNvPr id="7" name="Grafik 6">
-            <a:extLst>
-              <a:ext uri="{FF2B5EF4-FFF2-40B4-BE49-F238E27FC236}">
-                <a16:creationId xmlns:a16="http://schemas.microsoft.com/office/drawing/2014/main" id="{60664C2D-7CC0-1E3E-879F-624861F0723D}"/>
-              </a:ext>
-            </a:extLst>
-          </p:cNvPr>
-          <p:cNvPicPr>
-            <a:picLocks noChangeAspect="1"/>
-          </p:cNvPicPr>
-          <p:nvPr/>
-        </p:nvPicPr>
-        <p:blipFill>
-          <a:blip r:embed="rId2">
-            <a:extLst>
-              <a:ext uri="{28A0092B-C50C-407E-A947-70E740481C1C}">
-                <a14:useLocalDpi xmlns:a14="http://schemas.microsoft.com/office/drawing/2010/main" val="0"/>
-              </a:ext>
-            </a:extLst>
-          </a:blip>
-          <a:stretch>
-            <a:fillRect/>
-          </a:stretch>
-        </p:blipFill>
-        <p:spPr>
-          <a:xfrm>
-            <a:off x="300095" y="357099"/>
-            <a:ext cx="2649439" cy="2649439"/>
-          </a:xfrm>
-          <a:prstGeom prst="rect">
-            <a:avLst/>
-          </a:prstGeom>
-        </p:spPr>
-      </p:pic>
       <p:sp>
         <p:nvSpPr>
           <p:cNvPr id="18" name="Zierrahmen 17">
@@ -5608,369 +5935,6 @@
     <p:extLst>
       <p:ext uri="{BB962C8B-B14F-4D97-AF65-F5344CB8AC3E}">
         <p14:creationId xmlns:p14="http://schemas.microsoft.com/office/powerpoint/2010/main" val="415285027"/>
-      </p:ext>
-    </p:extLst>
-  </p:cSld>
-  <p:clrMapOvr>
-    <a:masterClrMapping/>
-  </p:clrMapOvr>
-</p:sld>
-</file>
-
-<file path=ppt/slides/slide4.xml><?xml version="1.0" encoding="utf-8"?>
-<p:sld xmlns:a="http://schemas.openxmlformats.org/drawingml/2006/main" xmlns:r="http://schemas.openxmlformats.org/officeDocument/2006/relationships" xmlns:p="http://schemas.openxmlformats.org/presentationml/2006/main">
-  <p:cSld>
-    <p:spTree>
-      <p:nvGrpSpPr>
-        <p:cNvPr id="1" name=""/>
-        <p:cNvGrpSpPr/>
-        <p:nvPr/>
-      </p:nvGrpSpPr>
-      <p:grpSpPr>
-        <a:xfrm>
-          <a:off x="0" y="0"/>
-          <a:ext cx="0" cy="0"/>
-          <a:chOff x="0" y="0"/>
-          <a:chExt cx="0" cy="0"/>
-        </a:xfrm>
-      </p:grpSpPr>
-      <p:sp>
-        <p:nvSpPr>
-          <p:cNvPr id="8" name="Freihandform: Form 7">
-            <a:extLst>
-              <a:ext uri="{FF2B5EF4-FFF2-40B4-BE49-F238E27FC236}">
-                <a16:creationId xmlns:a16="http://schemas.microsoft.com/office/drawing/2014/main" id="{8CDF04D5-40C1-D473-1A0C-67F3FD82D515}"/>
-              </a:ext>
-            </a:extLst>
-          </p:cNvPr>
-          <p:cNvSpPr/>
-          <p:nvPr/>
-        </p:nvSpPr>
-        <p:spPr>
-          <a:xfrm rot="19800000">
-            <a:off x="162768" y="1719631"/>
-            <a:ext cx="7200000" cy="1846906"/>
-          </a:xfrm>
-          <a:custGeom>
-            <a:avLst/>
-            <a:gdLst>
-              <a:gd name="csX0" fmla="*/ 6765499 w 7200000"/>
-              <a:gd name="csY0" fmla="*/ 252113 h 1846906"/>
-              <a:gd name="csX1" fmla="*/ 7200000 w 7200000"/>
-              <a:gd name="csY1" fmla="*/ 766906 h 1846906"/>
-              <a:gd name="csX2" fmla="*/ 3600000 w 7200000"/>
-              <a:gd name="csY2" fmla="*/ 1846906 h 1846906"/>
-              <a:gd name="csX3" fmla="*/ 0 w 7200000"/>
-              <a:gd name="csY3" fmla="*/ 766906 h 1846906"/>
-              <a:gd name="csX4" fmla="*/ 1054416 w 7200000"/>
-              <a:gd name="csY4" fmla="*/ 3231 h 1846906"/>
-              <a:gd name="csX5" fmla="*/ 1066264 w 7200000"/>
-              <a:gd name="csY5" fmla="*/ 0 h 1846906"/>
-              <a:gd name="csX6" fmla="*/ 1043666 w 7200000"/>
-              <a:gd name="csY6" fmla="*/ 9117 h 1846906"/>
-              <a:gd name="csX7" fmla="*/ 500451 w 7200000"/>
-              <a:gd name="csY7" fmla="*/ 545649 h 1846906"/>
-              <a:gd name="csX8" fmla="*/ 3681164 w 7200000"/>
-              <a:gd name="csY8" fmla="*/ 1505268 h 1846906"/>
-              <a:gd name="csX9" fmla="*/ 6861878 w 7200000"/>
-              <a:gd name="csY9" fmla="*/ 545649 h 1846906"/>
-              <a:gd name="csX10" fmla="*/ 6718880 w 7200000"/>
-              <a:gd name="csY10" fmla="*/ 260288 h 1846906"/>
-              <a:gd name="csX11" fmla="*/ 6624488 w 7200000"/>
-              <a:gd name="csY11" fmla="*/ 182480 h 1846906"/>
-            </a:gdLst>
-            <a:ahLst/>
-            <a:cxnLst>
-              <a:cxn ang="0">
-                <a:pos x="csX0" y="csY0"/>
-              </a:cxn>
-              <a:cxn ang="0">
-                <a:pos x="csX1" y="csY1"/>
-              </a:cxn>
-              <a:cxn ang="0">
-                <a:pos x="csX2" y="csY2"/>
-              </a:cxn>
-              <a:cxn ang="0">
-                <a:pos x="csX3" y="csY3"/>
-              </a:cxn>
-              <a:cxn ang="0">
-                <a:pos x="csX4" y="csY4"/>
-              </a:cxn>
-              <a:cxn ang="0">
-                <a:pos x="csX5" y="csY5"/>
-              </a:cxn>
-              <a:cxn ang="0">
-                <a:pos x="csX6" y="csY6"/>
-              </a:cxn>
-              <a:cxn ang="0">
-                <a:pos x="csX7" y="csY7"/>
-              </a:cxn>
-              <a:cxn ang="0">
-                <a:pos x="csX8" y="csY8"/>
-              </a:cxn>
-              <a:cxn ang="0">
-                <a:pos x="csX9" y="csY9"/>
-              </a:cxn>
-              <a:cxn ang="0">
-                <a:pos x="csX10" y="csY10"/>
-              </a:cxn>
-              <a:cxn ang="0">
-                <a:pos x="csX11" y="csY11"/>
-              </a:cxn>
-            </a:cxnLst>
-            <a:rect l="l" t="t" r="r" b="b"/>
-            <a:pathLst>
-              <a:path w="7200000" h="1846906">
-                <a:moveTo>
-                  <a:pt x="6765499" y="252113"/>
-                </a:moveTo>
-                <a:cubicBezTo>
-                  <a:pt x="7042600" y="405142"/>
-                  <a:pt x="7200000" y="580510"/>
-                  <a:pt x="7200000" y="766906"/>
-                </a:cubicBezTo>
-                <a:cubicBezTo>
-                  <a:pt x="7200000" y="1363374"/>
-                  <a:pt x="5588225" y="1846906"/>
-                  <a:pt x="3600000" y="1846906"/>
-                </a:cubicBezTo>
-                <a:cubicBezTo>
-                  <a:pt x="1611775" y="1846906"/>
-                  <a:pt x="0" y="1363374"/>
-                  <a:pt x="0" y="766906"/>
-                </a:cubicBezTo>
-                <a:cubicBezTo>
-                  <a:pt x="0" y="468672"/>
-                  <a:pt x="402944" y="198672"/>
-                  <a:pt x="1054416" y="3231"/>
-                </a:cubicBezTo>
-                <a:lnTo>
-                  <a:pt x="1066264" y="0"/>
-                </a:lnTo>
-                <a:lnTo>
-                  <a:pt x="1043666" y="9117"/>
-                </a:lnTo>
-                <a:cubicBezTo>
-                  <a:pt x="700708" y="162273"/>
-                  <a:pt x="500451" y="346905"/>
-                  <a:pt x="500451" y="545649"/>
-                </a:cubicBezTo>
-                <a:cubicBezTo>
-                  <a:pt x="500450" y="1075632"/>
-                  <a:pt x="1924505" y="1505268"/>
-                  <a:pt x="3681164" y="1505268"/>
-                </a:cubicBezTo>
-                <a:cubicBezTo>
-                  <a:pt x="5437825" y="1505268"/>
-                  <a:pt x="6861879" y="1075632"/>
-                  <a:pt x="6861878" y="545649"/>
-                </a:cubicBezTo>
-                <a:cubicBezTo>
-                  <a:pt x="6861878" y="446277"/>
-                  <a:pt x="6811814" y="350433"/>
-                  <a:pt x="6718880" y="260288"/>
-                </a:cubicBezTo>
-                <a:lnTo>
-                  <a:pt x="6624488" y="182480"/>
-                </a:lnTo>
-                <a:close/>
-              </a:path>
-            </a:pathLst>
-          </a:custGeom>
-          <a:gradFill>
-            <a:gsLst>
-              <a:gs pos="100000">
-                <a:srgbClr val="7C6FE1"/>
-              </a:gs>
-              <a:gs pos="0">
-                <a:srgbClr val="424CD0"/>
-              </a:gs>
-            </a:gsLst>
-            <a:lin ang="0" scaled="0"/>
-          </a:gradFill>
-          <a:ln>
-            <a:noFill/>
-          </a:ln>
-        </p:spPr>
-        <p:style>
-          <a:lnRef idx="2">
-            <a:schemeClr val="accent1">
-              <a:shade val="15000"/>
-            </a:schemeClr>
-          </a:lnRef>
-          <a:fillRef idx="1">
-            <a:schemeClr val="accent1"/>
-          </a:fillRef>
-          <a:effectRef idx="0">
-            <a:schemeClr val="accent1"/>
-          </a:effectRef>
-          <a:fontRef idx="minor">
-            <a:schemeClr val="lt1"/>
-          </a:fontRef>
-        </p:style>
-        <p:txBody>
-          <a:bodyPr wrap="square" rtlCol="0" anchor="ctr">
-            <a:noAutofit/>
-          </a:bodyPr>
-          <a:lstStyle/>
-          <a:p>
-            <a:pPr algn="ctr"/>
-            <a:endParaRPr lang="de-AT"/>
-          </a:p>
-        </p:txBody>
-      </p:sp>
-      <p:sp>
-        <p:nvSpPr>
-          <p:cNvPr id="6" name="Ellipse 5">
-            <a:extLst>
-              <a:ext uri="{FF2B5EF4-FFF2-40B4-BE49-F238E27FC236}">
-                <a16:creationId xmlns:a16="http://schemas.microsoft.com/office/drawing/2014/main" id="{9C6FF0E6-4E39-6A20-A086-1E7BC09924AD}"/>
-              </a:ext>
-            </a:extLst>
-          </p:cNvPr>
-          <p:cNvSpPr/>
-          <p:nvPr/>
-        </p:nvSpPr>
-        <p:spPr>
-          <a:xfrm rot="19800000">
-            <a:off x="3280507" y="3042693"/>
-            <a:ext cx="7200000" cy="2160000"/>
-          </a:xfrm>
-          <a:prstGeom prst="ellipse">
-            <a:avLst/>
-          </a:prstGeom>
-          <a:gradFill>
-            <a:gsLst>
-              <a:gs pos="100000">
-                <a:srgbClr val="7C6FE1"/>
-              </a:gs>
-              <a:gs pos="0">
-                <a:srgbClr val="424CD0"/>
-              </a:gs>
-            </a:gsLst>
-            <a:lin ang="0" scaled="0"/>
-          </a:gradFill>
-          <a:ln>
-            <a:noFill/>
-          </a:ln>
-        </p:spPr>
-        <p:style>
-          <a:lnRef idx="2">
-            <a:schemeClr val="accent1">
-              <a:shade val="15000"/>
-            </a:schemeClr>
-          </a:lnRef>
-          <a:fillRef idx="1">
-            <a:schemeClr val="accent1"/>
-          </a:fillRef>
-          <a:effectRef idx="0">
-            <a:schemeClr val="accent1"/>
-          </a:effectRef>
-          <a:fontRef idx="minor">
-            <a:schemeClr val="lt1"/>
-          </a:fontRef>
-        </p:style>
-        <p:txBody>
-          <a:bodyPr rtlCol="0" anchor="ctr"/>
-          <a:lstStyle/>
-          <a:p>
-            <a:pPr algn="ctr"/>
-            <a:endParaRPr lang="de-AT"/>
-          </a:p>
-        </p:txBody>
-      </p:sp>
-      <p:sp>
-        <p:nvSpPr>
-          <p:cNvPr id="7" name="Ellipse 6">
-            <a:extLst>
-              <a:ext uri="{FF2B5EF4-FFF2-40B4-BE49-F238E27FC236}">
-                <a16:creationId xmlns:a16="http://schemas.microsoft.com/office/drawing/2014/main" id="{3D62D169-E9A3-EB61-1F83-FA51E5E46D59}"/>
-              </a:ext>
-            </a:extLst>
-          </p:cNvPr>
-          <p:cNvSpPr/>
-          <p:nvPr/>
-        </p:nvSpPr>
-        <p:spPr>
-          <a:xfrm rot="19800000">
-            <a:off x="3724568" y="2863533"/>
-            <a:ext cx="6420723" cy="1926217"/>
-          </a:xfrm>
-          <a:prstGeom prst="ellipse">
-            <a:avLst/>
-          </a:prstGeom>
-          <a:solidFill>
-            <a:schemeClr val="bg1"/>
-          </a:solidFill>
-          <a:ln>
-            <a:noFill/>
-          </a:ln>
-        </p:spPr>
-        <p:style>
-          <a:lnRef idx="2">
-            <a:schemeClr val="accent1">
-              <a:shade val="15000"/>
-            </a:schemeClr>
-          </a:lnRef>
-          <a:fillRef idx="1">
-            <a:schemeClr val="accent1"/>
-          </a:fillRef>
-          <a:effectRef idx="0">
-            <a:schemeClr val="accent1"/>
-          </a:effectRef>
-          <a:fontRef idx="minor">
-            <a:schemeClr val="lt1"/>
-          </a:fontRef>
-        </p:style>
-        <p:txBody>
-          <a:bodyPr rtlCol="0" anchor="ctr"/>
-          <a:lstStyle/>
-          <a:p>
-            <a:pPr algn="ctr"/>
-            <a:endParaRPr lang="de-AT"/>
-          </a:p>
-        </p:txBody>
-      </p:sp>
-      <p:pic>
-        <p:nvPicPr>
-          <p:cNvPr id="13" name="Grafik 12">
-            <a:extLst>
-              <a:ext uri="{FF2B5EF4-FFF2-40B4-BE49-F238E27FC236}">
-                <a16:creationId xmlns:a16="http://schemas.microsoft.com/office/drawing/2014/main" id="{CCB98D3A-CEF0-BE6D-8279-E05FD762A062}"/>
-              </a:ext>
-            </a:extLst>
-          </p:cNvPr>
-          <p:cNvPicPr>
-            <a:picLocks noChangeAspect="1"/>
-          </p:cNvPicPr>
-          <p:nvPr/>
-        </p:nvPicPr>
-        <p:blipFill>
-          <a:blip r:embed="rId2">
-            <a:extLst>
-              <a:ext uri="{28A0092B-C50C-407E-A947-70E740481C1C}">
-                <a14:useLocalDpi xmlns:a14="http://schemas.microsoft.com/office/drawing/2010/main" val="0"/>
-              </a:ext>
-            </a:extLst>
-          </a:blip>
-          <a:stretch>
-            <a:fillRect/>
-          </a:stretch>
-        </p:blipFill>
-        <p:spPr>
-          <a:xfrm>
-            <a:off x="209372" y="339690"/>
-            <a:ext cx="2388551" cy="2388551"/>
-          </a:xfrm>
-          <a:prstGeom prst="rect">
-            <a:avLst/>
-          </a:prstGeom>
-        </p:spPr>
-      </p:pic>
-    </p:spTree>
-    <p:extLst>
-      <p:ext uri="{BB962C8B-B14F-4D97-AF65-F5344CB8AC3E}">
-        <p14:creationId xmlns:p14="http://schemas.microsoft.com/office/powerpoint/2010/main" val="3583143208"/>
       </p:ext>
     </p:extLst>
   </p:cSld>

</xml_diff>